<commit_message>
slides: Spanish deck as PDF
Exported from the Spanish pptx with LibreOffice; Georgia and Menlo embedded,
Carlito standing in for Calibri. Two lines shortened to fit the wider mono.
</commit_message>
<xml_diff>
--- a/slides/From-Cpp-to-the-Browser-JSConfMX-2026-ES.pptx
+++ b/slides/From-Cpp-to-the-Browser-JSConfMX-2026-ES.pptx
@@ -19079,7 +19079,7 @@
                 <a:cs typeface="Consolas"/>
                 <a:sym typeface="Consolas"/>
               </a:rPr>
-              <a:t>kevinwkt.github.io/from-cpp-to-the-browser/demo    teclas: 1 2 3 4 pestañas · R carrera (2 o 4) · S sorpresa · Z alejar · 0 reset</a:t>
+              <a:t>kevinwkt.github.io/from-cpp-to-the-browser/demo    teclas: 1 2 3 4 · R carrera (2 o 4) · S sorpresa · Z alejar · 0 reset</a:t>
             </a:r>
             <a:endParaRPr/>
           </a:p>
@@ -30992,7 +30992,7 @@
                 <a:cs typeface="Consolas"/>
                 <a:sym typeface="Consolas"/>
               </a:rPr>
-              <a:t>→ inalcanzable: eliminado</a:t>
+              <a:t>→ inalcanzable: fuera</a:t>
             </a:r>
           </a:p>
         </p:txBody>

</xml_diff>

<commit_message>
slides: Spanish deck, no overlapping text
Four headings and one gloss shortened where the longer Spanish wrapped
into the line below (slides 2 and 10); every page checked for overlapping
text lines.
</commit_message>
<xml_diff>
--- a/slides/From-Cpp-to-the-Browser-JSConfMX-2026-ES.pptx
+++ b/slides/From-Cpp-to-the-Browser-JSConfMX-2026-ES.pptx
@@ -13192,7 +13192,7 @@
                 <a:cs typeface="Georgia"/>
                 <a:sym typeface="Georgia"/>
               </a:rPr>
-              <a:t>Eliminación de código muerto</a:t>
+              <a:t>Código muerto, fuera</a:t>
             </a:r>
             <a:endParaRPr/>
           </a:p>
@@ -14343,7 +14343,7 @@
                 <a:cs typeface="Calibri"/>
                 <a:sym typeface="Calibri"/>
               </a:rPr>
-              <a:t>las locales se vuelven valores SSA: el 9 → 3 de la diapositiva 11</a:t>
+              <a:t>locales → valores SSA: el 9 → 3 de la diapo 11</a:t>
             </a:r>
           </a:p>
           <a:p>
@@ -23649,7 +23649,7 @@
                 <a:cs typeface="Georgia"/>
                 <a:sym typeface="Georgia"/>
               </a:rPr>
-              <a:t>Ya estás enviando WebAssembly a producción</a:t>
+              <a:t>Ya usas WebAssembly en producción</a:t>
             </a:r>
             <a:endParaRPr/>
           </a:p>
@@ -24901,7 +24901,7 @@
                 <a:cs typeface="Georgia"/>
                 <a:sym typeface="Georgia"/>
               </a:rPr>
-              <a:t>Tus dependencias de npm</a:t>
+              <a:t>Tus paquetes npm</a:t>
             </a:r>
             <a:endParaRPr/>
           </a:p>

</xml_diff>